<commit_message>
Day 1 afternoon nosoln accessible: convert 10 OLE equations; fix 8 Symbol PUA chars
Co-Authored-By: Claude Opus 4.8 <noreply@anthropic.com>
</commit_message>
<xml_diff>
--- a/Day1_Probability/FW536_Day1_Afternoon Distributions I_nosoln_accessible.pptx
+++ b/Day1_Probability/FW536_Day1_Afternoon Distributions I_nosoln_accessible.pptx
@@ -8413,95 +8413,6 @@
           </a:p>
         </p:txBody>
       </p:sp>
-      <p:graphicFrame>
-        <p:nvGraphicFramePr>
-          <p:cNvPr id="157699" name="Object 4"/>
-          <p:cNvGraphicFramePr>
-            <a:graphicFrameLocks noChangeAspect="1"/>
-          </p:cNvGraphicFramePr>
-          <p:nvPr>
-            <p:extLst>
-              <p:ext uri="{D42A27DB-BD31-4B8C-83A1-F6EECF244321}">
-                <p14:modId xmlns:p14="http://schemas.microsoft.com/office/powerpoint/2010/main" val="1473999975"/>
-              </p:ext>
-            </p:extLst>
-          </p:nvPr>
-        </p:nvGraphicFramePr>
-        <p:xfrm>
-          <a:off x="3468130" y="4590536"/>
-          <a:ext cx="3810000" cy="690563"/>
-        </p:xfrm>
-        <a:graphic>
-          <a:graphicData uri="http://schemas.openxmlformats.org/presentationml/2006/ole">
-            <mc:AlternateContent xmlns:mc="http://schemas.openxmlformats.org/markup-compatibility/2006">
-              <mc:Choice xmlns:v="urn:schemas-microsoft-com:vml" Requires="v">
-                <p:oleObj name="Equation" r:id="rId3" imgW="2311078" imgH="418893" progId="">
-                  <p:embed/>
-                </p:oleObj>
-              </mc:Choice>
-              <mc:Fallback>
-                <p:oleObj name="Equation" r:id="rId3" imgW="2311078" imgH="418893" progId="">
-                  <p:embed/>
-                  <p:pic>
-                    <p:nvPicPr>
-                      <p:cNvPr id="0" name=""/>
-                      <p:cNvPicPr>
-                        <a:picLocks noChangeAspect="1" noChangeArrowheads="1"/>
-                      </p:cNvPicPr>
-                      <p:nvPr/>
-                    </p:nvPicPr>
-                    <p:blipFill>
-                      <a:blip r:embed="rId4">
-                        <a:extLst>
-                          <a:ext uri="{28A0092B-C50C-407E-A947-70E740481C1C}">
-                            <a14:useLocalDpi xmlns:a14="http://schemas.microsoft.com/office/drawing/2010/main" val="0"/>
-                          </a:ext>
-                        </a:extLst>
-                      </a:blip>
-                      <a:srcRect/>
-                      <a:stretch>
-                        <a:fillRect/>
-                      </a:stretch>
-                    </p:blipFill>
-                    <p:spPr bwMode="auto">
-                      <a:xfrm>
-                        <a:off x="3468130" y="4590536"/>
-                        <a:ext cx="3810000" cy="690563"/>
-                      </a:xfrm>
-                      <a:prstGeom prst="rect">
-                        <a:avLst/>
-                      </a:prstGeom>
-                      <a:noFill/>
-                      <a:ln>
-                        <a:noFill/>
-                      </a:ln>
-                      <a:extLst>
-                        <a:ext uri="{909E8E84-426E-40DD-AFC4-6F175D3DCCD1}">
-                          <a14:hiddenFill xmlns:a14="http://schemas.microsoft.com/office/drawing/2010/main">
-                            <a:solidFill>
-                              <a:srgbClr val="FFFFFF"/>
-                            </a:solidFill>
-                          </a14:hiddenFill>
-                        </a:ext>
-                        <a:ext uri="{91240B29-F687-4F45-9708-019B960494DF}">
-                          <a14:hiddenLine xmlns:a14="http://schemas.microsoft.com/office/drawing/2010/main" w="9525">
-                            <a:solidFill>
-                              <a:schemeClr val="tx1"/>
-                            </a:solidFill>
-                            <a:miter lim="800000"/>
-                            <a:headEnd/>
-                            <a:tailEnd/>
-                          </a14:hiddenLine>
-                        </a:ext>
-                      </a:extLst>
-                    </p:spPr>
-                  </p:pic>
-                </p:oleObj>
-              </mc:Fallback>
-            </mc:AlternateContent>
-          </a:graphicData>
-        </a:graphic>
-      </p:graphicFrame>
       <p:sp>
         <p:nvSpPr>
           <p:cNvPr id="2" name="TextBox 1">
@@ -8537,6 +8448,103 @@
                 </a:solidFill>
               </a:rPr>
               <a:t>Group Work</a:t>
+            </a:r>
+          </a:p>
+        </p:txBody>
+      </p:sp>
+      <p:sp>
+        <p:nvSpPr>
+          <p:cNvPr id="12292" name="TextBox 12291"/>
+          <p:cNvSpPr txBox="1"/>
+          <p:nvPr/>
+        </p:nvSpPr>
+        <p:spPr>
+          <a:xfrm>
+            <a:off x="3468130" y="4590536"/>
+            <a:ext cx="6893169" cy="690563"/>
+          </a:xfrm>
+          <a:prstGeom prst="rect">
+            <a:avLst/>
+          </a:prstGeom>
+          <a:noFill/>
+        </p:spPr>
+        <p:txBody>
+          <a:bodyPr wrap="square" anchor="ctr" lIns="0" rIns="0" tIns="0" bIns="0">
+            <a:spAutoFit/>
+          </a:bodyPr>
+          <a:lstStyle/>
+          <a:p>
+            <a:r>
+              <a:rPr sz="1900">
+                <a:latin typeface="Cambria"/>
+              </a:rPr>
+              <a:t>P(x) = </a:t>
+            </a:r>
+            <a:r>
+              <a:rPr sz="1900" baseline="-25000">
+                <a:latin typeface="Cambria"/>
+              </a:rPr>
+              <a:t>n</a:t>
+            </a:r>
+            <a:r>
+              <a:rPr sz="1900">
+                <a:latin typeface="Cambria"/>
+              </a:rPr>
+              <a:t>C</a:t>
+            </a:r>
+            <a:r>
+              <a:rPr sz="1900" baseline="-25000">
+                <a:latin typeface="Cambria"/>
+              </a:rPr>
+              <a:t>x</a:t>
+            </a:r>
+            <a:r>
+              <a:rPr sz="1900">
+                <a:latin typeface="Cambria"/>
+              </a:rPr>
+              <a:t> p</a:t>
+            </a:r>
+            <a:r>
+              <a:rPr sz="1900" baseline="30000">
+                <a:latin typeface="Cambria"/>
+              </a:rPr>
+              <a:t>x</a:t>
+            </a:r>
+            <a:r>
+              <a:rPr sz="1900">
+                <a:latin typeface="Cambria"/>
+              </a:rPr>
+              <a:t> q</a:t>
+            </a:r>
+            <a:r>
+              <a:rPr sz="1900" baseline="30000">
+                <a:latin typeface="Cambria"/>
+              </a:rPr>
+              <a:t>n−x</a:t>
+            </a:r>
+            <a:r>
+              <a:rPr sz="1900">
+                <a:latin typeface="Cambria"/>
+              </a:rPr>
+              <a:t> = n! / ((n − x)! x!) · p</a:t>
+            </a:r>
+            <a:r>
+              <a:rPr sz="1900" baseline="30000">
+                <a:latin typeface="Cambria"/>
+              </a:rPr>
+              <a:t>x</a:t>
+            </a:r>
+            <a:r>
+              <a:rPr sz="1900">
+                <a:latin typeface="Cambria"/>
+              </a:rPr>
+              <a:t> q</a:t>
+            </a:r>
+            <a:r>
+              <a:rPr sz="1900" baseline="30000">
+                <a:latin typeface="Cambria"/>
+              </a:rPr>
+              <a:t>n−x</a:t>
             </a:r>
           </a:p>
         </p:txBody>
@@ -9764,10 +9772,8 @@
               <a:t>We usually work with the log-likelihood. Can you find that? </a:t>
             </a:r>
             <a:r>
-              <a:rPr lang="en-US" dirty="0">
-                <a:sym typeface="Wingdings"/>
-              </a:rPr>
-              <a:t> </a:t>
+              <a:rPr lang="en-US" dirty="0"/>
+              <a:t>→ </a:t>
             </a:r>
             <a:r>
               <a:rPr lang="en-US" dirty="0"/>
@@ -12881,140 +12887,6 @@
           </a:p>
         </p:txBody>
       </p:sp>
-      <p:graphicFrame>
-        <p:nvGraphicFramePr>
-          <p:cNvPr id="189443" name="Object 4"/>
-          <p:cNvGraphicFramePr>
-            <a:graphicFrameLocks noGrp="1" noChangeAspect="1"/>
-          </p:cNvGraphicFramePr>
-          <p:nvPr>
-            <p:ph sz="quarter" idx="2"/>
-          </p:nvPr>
-        </p:nvGraphicFramePr>
-        <p:xfrm>
-          <a:off x="4397471" y="2509997"/>
-          <a:ext cx="2054225" cy="728412"/>
-        </p:xfrm>
-        <a:graphic>
-          <a:graphicData uri="http://schemas.openxmlformats.org/presentationml/2006/ole">
-            <mc:AlternateContent xmlns:mc="http://schemas.openxmlformats.org/markup-compatibility/2006">
-              <mc:Choice xmlns:v="urn:schemas-microsoft-com:vml" Requires="v">
-                <p:oleObj name="Equation" r:id="rId3" imgW="1180588" imgH="418918" progId="Equation.DSMT4">
-                  <p:embed/>
-                </p:oleObj>
-              </mc:Choice>
-              <mc:Fallback>
-                <p:oleObj name="Equation" r:id="rId3" imgW="1180588" imgH="418918" progId="Equation.DSMT4">
-                  <p:embed/>
-                  <p:pic>
-                    <p:nvPicPr>
-                      <p:cNvPr id="0" name=""/>
-                      <p:cNvPicPr>
-                        <a:picLocks noChangeAspect="1" noChangeArrowheads="1"/>
-                      </p:cNvPicPr>
-                      <p:nvPr/>
-                    </p:nvPicPr>
-                    <p:blipFill>
-                      <a:blip r:embed="rId4">
-                        <a:extLst>
-                          <a:ext uri="{28A0092B-C50C-407E-A947-70E740481C1C}">
-                            <a14:useLocalDpi xmlns:a14="http://schemas.microsoft.com/office/drawing/2010/main" val="0"/>
-                          </a:ext>
-                        </a:extLst>
-                      </a:blip>
-                      <a:srcRect/>
-                      <a:stretch>
-                        <a:fillRect/>
-                      </a:stretch>
-                    </p:blipFill>
-                    <p:spPr bwMode="auto">
-                      <a:xfrm>
-                        <a:off x="4397471" y="2509997"/>
-                        <a:ext cx="2054225" cy="728412"/>
-                      </a:xfrm>
-                      <a:prstGeom prst="rect">
-                        <a:avLst/>
-                      </a:prstGeom>
-                      <a:noFill/>
-                      <a:ln>
-                        <a:noFill/>
-                      </a:ln>
-                      <a:effectLst/>
-                    </p:spPr>
-                  </p:pic>
-                </p:oleObj>
-              </mc:Fallback>
-            </mc:AlternateContent>
-          </a:graphicData>
-        </a:graphic>
-      </p:graphicFrame>
-      <p:graphicFrame>
-        <p:nvGraphicFramePr>
-          <p:cNvPr id="191492" name="Object 6"/>
-          <p:cNvGraphicFramePr>
-            <a:graphicFrameLocks noGrp="1" noChangeAspect="1"/>
-          </p:cNvGraphicFramePr>
-          <p:nvPr>
-            <p:ph sz="quarter" idx="3"/>
-          </p:nvPr>
-        </p:nvGraphicFramePr>
-        <p:xfrm>
-          <a:off x="4297990" y="4872555"/>
-          <a:ext cx="3616658" cy="947220"/>
-        </p:xfrm>
-        <a:graphic>
-          <a:graphicData uri="http://schemas.openxmlformats.org/presentationml/2006/ole">
-            <mc:AlternateContent xmlns:mc="http://schemas.openxmlformats.org/markup-compatibility/2006">
-              <mc:Choice xmlns:v="urn:schemas-microsoft-com:vml" Requires="v">
-                <p:oleObj name="Equation" r:id="rId5" imgW="1651000" imgH="431800" progId="Equation.DSMT4">
-                  <p:embed/>
-                </p:oleObj>
-              </mc:Choice>
-              <mc:Fallback>
-                <p:oleObj name="Equation" r:id="rId5" imgW="1651000" imgH="431800" progId="Equation.DSMT4">
-                  <p:embed/>
-                  <p:pic>
-                    <p:nvPicPr>
-                      <p:cNvPr id="0" name=""/>
-                      <p:cNvPicPr>
-                        <a:picLocks noChangeAspect="1" noChangeArrowheads="1"/>
-                      </p:cNvPicPr>
-                      <p:nvPr/>
-                    </p:nvPicPr>
-                    <p:blipFill>
-                      <a:blip r:embed="rId6">
-                        <a:extLst>
-                          <a:ext uri="{28A0092B-C50C-407E-A947-70E740481C1C}">
-                            <a14:useLocalDpi xmlns:a14="http://schemas.microsoft.com/office/drawing/2010/main" val="0"/>
-                          </a:ext>
-                        </a:extLst>
-                      </a:blip>
-                      <a:srcRect/>
-                      <a:stretch>
-                        <a:fillRect/>
-                      </a:stretch>
-                    </p:blipFill>
-                    <p:spPr bwMode="auto">
-                      <a:xfrm>
-                        <a:off x="4297990" y="4872555"/>
-                        <a:ext cx="3616658" cy="947220"/>
-                      </a:xfrm>
-                      <a:prstGeom prst="rect">
-                        <a:avLst/>
-                      </a:prstGeom>
-                      <a:noFill/>
-                      <a:ln>
-                        <a:noFill/>
-                      </a:ln>
-                      <a:effectLst/>
-                    </p:spPr>
-                  </p:pic>
-                </p:oleObj>
-              </mc:Fallback>
-            </mc:AlternateContent>
-          </a:graphicData>
-        </a:graphic>
-      </p:graphicFrame>
       <p:sp>
         <p:nvSpPr>
           <p:cNvPr id="191493" name="TextBox 191492"/>
@@ -13127,6 +12999,100 @@
                 <a:latin typeface="Cambria"/>
               </a:rPr>
               <a:t> / k!</a:t>
+            </a:r>
+          </a:p>
+        </p:txBody>
+      </p:sp>
+      <p:sp>
+        <p:nvSpPr>
+          <p:cNvPr id="191495" name="TextBox 191494"/>
+          <p:cNvSpPr txBox="1"/>
+          <p:nvPr/>
+        </p:nvSpPr>
+        <p:spPr>
+          <a:xfrm>
+            <a:off x="4397471" y="2509997"/>
+            <a:ext cx="3094892" cy="728412"/>
+          </a:xfrm>
+          <a:prstGeom prst="rect">
+            <a:avLst/>
+          </a:prstGeom>
+          <a:noFill/>
+        </p:spPr>
+        <p:txBody>
+          <a:bodyPr wrap="square" anchor="ctr" lIns="0" rIns="0" tIns="0" bIns="0">
+            <a:spAutoFit/>
+          </a:bodyPr>
+          <a:lstStyle/>
+          <a:p>
+            <a:r>
+              <a:rPr sz="1900">
+                <a:latin typeface="Cambria"/>
+              </a:rPr>
+              <a:t>P(X = x) = μ</a:t>
+            </a:r>
+            <a:r>
+              <a:rPr sz="1900" baseline="30000">
+                <a:latin typeface="Cambria"/>
+              </a:rPr>
+              <a:t>x</a:t>
+            </a:r>
+            <a:r>
+              <a:rPr sz="1900">
+                <a:latin typeface="Cambria"/>
+              </a:rPr>
+              <a:t> e</a:t>
+            </a:r>
+            <a:r>
+              <a:rPr sz="1900" baseline="30000">
+                <a:latin typeface="Cambria"/>
+              </a:rPr>
+              <a:t>−μ</a:t>
+            </a:r>
+            <a:r>
+              <a:rPr sz="1900">
+                <a:latin typeface="Cambria"/>
+              </a:rPr>
+              <a:t> / x!</a:t>
+            </a:r>
+          </a:p>
+        </p:txBody>
+      </p:sp>
+      <p:sp>
+        <p:nvSpPr>
+          <p:cNvPr id="191496" name="TextBox 191495"/>
+          <p:cNvSpPr txBox="1"/>
+          <p:nvPr/>
+        </p:nvSpPr>
+        <p:spPr>
+          <a:xfrm>
+            <a:off x="4297990" y="4872555"/>
+            <a:ext cx="3616658" cy="947220"/>
+          </a:xfrm>
+          <a:prstGeom prst="rect">
+            <a:avLst/>
+          </a:prstGeom>
+          <a:noFill/>
+        </p:spPr>
+        <p:txBody>
+          <a:bodyPr wrap="square" anchor="ctr" lIns="0" rIns="0" tIns="0" bIns="0">
+            <a:spAutoFit/>
+          </a:bodyPr>
+          <a:lstStyle/>
+          <a:p>
+            <a:r>
+              <a:rPr sz="1800">
+                <a:latin typeface="Cambria"/>
+              </a:rPr>
+              <a:t>Mean : μ (rate per interval)</a:t>
+            </a:r>
+          </a:p>
+          <a:p>
+            <a:r>
+              <a:rPr sz="1800">
+                <a:latin typeface="Cambria"/>
+              </a:rPr>
+              <a:t>Variance : μ</a:t>
             </a:r>
           </a:p>
         </p:txBody>
@@ -13811,10 +13777,8 @@
                 <a:t> </a:t>
               </a:r>
               <a:r>
-                <a:rPr lang="en-US" altLang="en-US" sz="2000" dirty="0">
-                  <a:sym typeface="Wingdings" charset="2"/>
-                </a:rPr>
-                <a:t> 0</a:t>
+                <a:rPr lang="en-US" altLang="en-US" sz="2000" dirty="0"/>
+                <a:t>→ 0</a:t>
               </a:r>
               <a:endParaRPr lang="en-US" altLang="en-US" sz="2000" dirty="0"/>
             </a:p>
@@ -15533,150 +15497,6 @@
           </a:p>
         </p:txBody>
       </p:sp>
-      <p:graphicFrame>
-        <p:nvGraphicFramePr>
-          <p:cNvPr id="189443" name="Object 4"/>
-          <p:cNvGraphicFramePr>
-            <a:graphicFrameLocks noGrp="1" noChangeAspect="1"/>
-          </p:cNvGraphicFramePr>
-          <p:nvPr>
-            <p:ph sz="quarter" idx="2"/>
-            <p:extLst>
-              <p:ext uri="{D42A27DB-BD31-4B8C-83A1-F6EECF244321}">
-                <p14:modId xmlns:p14="http://schemas.microsoft.com/office/powerpoint/2010/main" val="368061340"/>
-              </p:ext>
-            </p:extLst>
-          </p:nvPr>
-        </p:nvGraphicFramePr>
-        <p:xfrm>
-          <a:off x="4397471" y="2509997"/>
-          <a:ext cx="2054225" cy="728412"/>
-        </p:xfrm>
-        <a:graphic>
-          <a:graphicData uri="http://schemas.openxmlformats.org/presentationml/2006/ole">
-            <mc:AlternateContent xmlns:mc="http://schemas.openxmlformats.org/markup-compatibility/2006">
-              <mc:Choice xmlns:v="urn:schemas-microsoft-com:vml" Requires="v">
-                <p:oleObj name="Equation" r:id="rId3" imgW="1180588" imgH="418918" progId="Equation.DSMT4">
-                  <p:embed/>
-                </p:oleObj>
-              </mc:Choice>
-              <mc:Fallback>
-                <p:oleObj name="Equation" r:id="rId3" imgW="1180588" imgH="418918" progId="Equation.DSMT4">
-                  <p:embed/>
-                  <p:pic>
-                    <p:nvPicPr>
-                      <p:cNvPr id="0" name=""/>
-                      <p:cNvPicPr>
-                        <a:picLocks noChangeAspect="1" noChangeArrowheads="1"/>
-                      </p:cNvPicPr>
-                      <p:nvPr/>
-                    </p:nvPicPr>
-                    <p:blipFill>
-                      <a:blip r:embed="rId4">
-                        <a:extLst>
-                          <a:ext uri="{28A0092B-C50C-407E-A947-70E740481C1C}">
-                            <a14:useLocalDpi xmlns:a14="http://schemas.microsoft.com/office/drawing/2010/main" val="0"/>
-                          </a:ext>
-                        </a:extLst>
-                      </a:blip>
-                      <a:srcRect/>
-                      <a:stretch>
-                        <a:fillRect/>
-                      </a:stretch>
-                    </p:blipFill>
-                    <p:spPr bwMode="auto">
-                      <a:xfrm>
-                        <a:off x="4397471" y="2509997"/>
-                        <a:ext cx="2054225" cy="728412"/>
-                      </a:xfrm>
-                      <a:prstGeom prst="rect">
-                        <a:avLst/>
-                      </a:prstGeom>
-                      <a:noFill/>
-                      <a:ln>
-                        <a:noFill/>
-                      </a:ln>
-                      <a:effectLst/>
-                    </p:spPr>
-                  </p:pic>
-                </p:oleObj>
-              </mc:Fallback>
-            </mc:AlternateContent>
-          </a:graphicData>
-        </a:graphic>
-      </p:graphicFrame>
-      <p:graphicFrame>
-        <p:nvGraphicFramePr>
-          <p:cNvPr id="191492" name="Object 6"/>
-          <p:cNvGraphicFramePr>
-            <a:graphicFrameLocks noGrp="1" noChangeAspect="1"/>
-          </p:cNvGraphicFramePr>
-          <p:nvPr>
-            <p:ph sz="quarter" idx="3"/>
-            <p:extLst>
-              <p:ext uri="{D42A27DB-BD31-4B8C-83A1-F6EECF244321}">
-                <p14:modId xmlns:p14="http://schemas.microsoft.com/office/powerpoint/2010/main" val="276206557"/>
-              </p:ext>
-            </p:extLst>
-          </p:nvPr>
-        </p:nvGraphicFramePr>
-        <p:xfrm>
-          <a:off x="4297990" y="4872555"/>
-          <a:ext cx="3616658" cy="947220"/>
-        </p:xfrm>
-        <a:graphic>
-          <a:graphicData uri="http://schemas.openxmlformats.org/presentationml/2006/ole">
-            <mc:AlternateContent xmlns:mc="http://schemas.openxmlformats.org/markup-compatibility/2006">
-              <mc:Choice xmlns:v="urn:schemas-microsoft-com:vml" Requires="v">
-                <p:oleObj name="Equation" r:id="rId5" imgW="1651000" imgH="431800" progId="Equation.DSMT4">
-                  <p:embed/>
-                </p:oleObj>
-              </mc:Choice>
-              <mc:Fallback>
-                <p:oleObj name="Equation" r:id="rId5" imgW="1651000" imgH="431800" progId="Equation.DSMT4">
-                  <p:embed/>
-                  <p:pic>
-                    <p:nvPicPr>
-                      <p:cNvPr id="0" name=""/>
-                      <p:cNvPicPr>
-                        <a:picLocks noChangeAspect="1" noChangeArrowheads="1"/>
-                      </p:cNvPicPr>
-                      <p:nvPr/>
-                    </p:nvPicPr>
-                    <p:blipFill>
-                      <a:blip r:embed="rId6">
-                        <a:extLst>
-                          <a:ext uri="{28A0092B-C50C-407E-A947-70E740481C1C}">
-                            <a14:useLocalDpi xmlns:a14="http://schemas.microsoft.com/office/drawing/2010/main" val="0"/>
-                          </a:ext>
-                        </a:extLst>
-                      </a:blip>
-                      <a:srcRect/>
-                      <a:stretch>
-                        <a:fillRect/>
-                      </a:stretch>
-                    </p:blipFill>
-                    <p:spPr bwMode="auto">
-                      <a:xfrm>
-                        <a:off x="4297990" y="4872555"/>
-                        <a:ext cx="3616658" cy="947220"/>
-                      </a:xfrm>
-                      <a:prstGeom prst="rect">
-                        <a:avLst/>
-                      </a:prstGeom>
-                      <a:noFill/>
-                      <a:ln>
-                        <a:noFill/>
-                      </a:ln>
-                      <a:effectLst/>
-                    </p:spPr>
-                  </p:pic>
-                </p:oleObj>
-              </mc:Fallback>
-            </mc:AlternateContent>
-          </a:graphicData>
-        </a:graphic>
-      </p:graphicFrame>
       <p:sp>
         <p:nvSpPr>
           <p:cNvPr id="191493" name="TextBox 191492"/>
@@ -15789,6 +15609,100 @@
                 <a:latin typeface="Cambria"/>
               </a:rPr>
               <a:t> / k!</a:t>
+            </a:r>
+          </a:p>
+        </p:txBody>
+      </p:sp>
+      <p:sp>
+        <p:nvSpPr>
+          <p:cNvPr id="191495" name="TextBox 191494"/>
+          <p:cNvSpPr txBox="1"/>
+          <p:nvPr/>
+        </p:nvSpPr>
+        <p:spPr>
+          <a:xfrm>
+            <a:off x="4397471" y="2509997"/>
+            <a:ext cx="3094892" cy="728412"/>
+          </a:xfrm>
+          <a:prstGeom prst="rect">
+            <a:avLst/>
+          </a:prstGeom>
+          <a:noFill/>
+        </p:spPr>
+        <p:txBody>
+          <a:bodyPr wrap="square" anchor="ctr" lIns="0" rIns="0" tIns="0" bIns="0">
+            <a:spAutoFit/>
+          </a:bodyPr>
+          <a:lstStyle/>
+          <a:p>
+            <a:r>
+              <a:rPr sz="1900">
+                <a:latin typeface="Cambria"/>
+              </a:rPr>
+              <a:t>P(X = x) = μ</a:t>
+            </a:r>
+            <a:r>
+              <a:rPr sz="1900" baseline="30000">
+                <a:latin typeface="Cambria"/>
+              </a:rPr>
+              <a:t>x</a:t>
+            </a:r>
+            <a:r>
+              <a:rPr sz="1900">
+                <a:latin typeface="Cambria"/>
+              </a:rPr>
+              <a:t> e</a:t>
+            </a:r>
+            <a:r>
+              <a:rPr sz="1900" baseline="30000">
+                <a:latin typeface="Cambria"/>
+              </a:rPr>
+              <a:t>−μ</a:t>
+            </a:r>
+            <a:r>
+              <a:rPr sz="1900">
+                <a:latin typeface="Cambria"/>
+              </a:rPr>
+              <a:t> / x!</a:t>
+            </a:r>
+          </a:p>
+        </p:txBody>
+      </p:sp>
+      <p:sp>
+        <p:nvSpPr>
+          <p:cNvPr id="191496" name="TextBox 191495"/>
+          <p:cNvSpPr txBox="1"/>
+          <p:nvPr/>
+        </p:nvSpPr>
+        <p:spPr>
+          <a:xfrm>
+            <a:off x="4297990" y="4872555"/>
+            <a:ext cx="3616658" cy="947220"/>
+          </a:xfrm>
+          <a:prstGeom prst="rect">
+            <a:avLst/>
+          </a:prstGeom>
+          <a:noFill/>
+        </p:spPr>
+        <p:txBody>
+          <a:bodyPr wrap="square" anchor="ctr" lIns="0" rIns="0" tIns="0" bIns="0">
+            <a:spAutoFit/>
+          </a:bodyPr>
+          <a:lstStyle/>
+          <a:p>
+            <a:r>
+              <a:rPr sz="1800">
+                <a:latin typeface="Cambria"/>
+              </a:rPr>
+              <a:t>Mean : μ (rate per interval)</a:t>
+            </a:r>
+          </a:p>
+          <a:p>
+            <a:r>
+              <a:rPr sz="1800">
+                <a:latin typeface="Cambria"/>
+              </a:rPr>
+              <a:t>Variance : μ</a:t>
             </a:r>
           </a:p>
         </p:txBody>
@@ -16261,10 +16175,8 @@
               <a:defRPr/>
             </a:pPr>
             <a:r>
-              <a:rPr lang="en-US" altLang="en-US" sz="2400" i="0">
-                <a:sym typeface="Symbol" charset="2"/>
-              </a:rPr>
-              <a:t>=2</a:t>
+              <a:rPr lang="en-US" altLang="en-US" sz="2400" i="0"/>
+              <a:t>μ=2</a:t>
             </a:r>
           </a:p>
         </p:txBody>
@@ -16428,10 +16340,8 @@
               <a:defRPr/>
             </a:pPr>
             <a:r>
-              <a:rPr lang="en-US" altLang="en-US" sz="2400" i="0">
-                <a:sym typeface="Symbol" charset="2"/>
-              </a:rPr>
-              <a:t>=5</a:t>
+              <a:rPr lang="en-US" altLang="en-US" sz="2400" i="0"/>
+              <a:t>μ=5</a:t>
             </a:r>
           </a:p>
         </p:txBody>
@@ -16595,10 +16505,8 @@
               <a:defRPr/>
             </a:pPr>
             <a:r>
-              <a:rPr lang="en-US" altLang="en-US" sz="2400" i="0">
-                <a:sym typeface="Symbol" charset="2"/>
-              </a:rPr>
-              <a:t>=8</a:t>
+              <a:rPr lang="en-US" altLang="en-US" sz="2400" i="0"/>
+              <a:t>μ=8</a:t>
             </a:r>
           </a:p>
         </p:txBody>
@@ -16738,77 +16646,6 @@
           </a:p>
         </p:txBody>
       </p:sp>
-      <p:graphicFrame>
-        <p:nvGraphicFramePr>
-          <p:cNvPr id="4" name="Object 4"/>
-          <p:cNvGraphicFramePr>
-            <a:graphicFrameLocks noChangeAspect="1"/>
-          </p:cNvGraphicFramePr>
-          <p:nvPr>
-            <p:extLst>
-              <p:ext uri="{D42A27DB-BD31-4B8C-83A1-F6EECF244321}">
-                <p14:modId xmlns:p14="http://schemas.microsoft.com/office/powerpoint/2010/main" val="1764011272"/>
-              </p:ext>
-            </p:extLst>
-          </p:nvPr>
-        </p:nvGraphicFramePr>
-        <p:xfrm>
-          <a:off x="4818820" y="4919723"/>
-          <a:ext cx="2554360" cy="905756"/>
-        </p:xfrm>
-        <a:graphic>
-          <a:graphicData uri="http://schemas.openxmlformats.org/presentationml/2006/ole">
-            <mc:AlternateContent xmlns:mc="http://schemas.openxmlformats.org/markup-compatibility/2006">
-              <mc:Choice xmlns:v="urn:schemas-microsoft-com:vml" Requires="v">
-                <p:oleObj name="Equation" r:id="rId3" imgW="1180588" imgH="418918" progId="Equation.DSMT4">
-                  <p:embed/>
-                </p:oleObj>
-              </mc:Choice>
-              <mc:Fallback>
-                <p:oleObj name="Equation" r:id="rId3" imgW="1180588" imgH="418918" progId="Equation.DSMT4">
-                  <p:embed/>
-                  <p:pic>
-                    <p:nvPicPr>
-                      <p:cNvPr id="0" name=""/>
-                      <p:cNvPicPr>
-                        <a:picLocks noChangeAspect="1" noChangeArrowheads="1"/>
-                      </p:cNvPicPr>
-                      <p:nvPr/>
-                    </p:nvPicPr>
-                    <p:blipFill>
-                      <a:blip r:embed="rId4">
-                        <a:extLst>
-                          <a:ext uri="{28A0092B-C50C-407E-A947-70E740481C1C}">
-                            <a14:useLocalDpi xmlns:a14="http://schemas.microsoft.com/office/drawing/2010/main" val="0"/>
-                          </a:ext>
-                        </a:extLst>
-                      </a:blip>
-                      <a:srcRect/>
-                      <a:stretch>
-                        <a:fillRect/>
-                      </a:stretch>
-                    </p:blipFill>
-                    <p:spPr bwMode="auto">
-                      <a:xfrm>
-                        <a:off x="4818820" y="4919723"/>
-                        <a:ext cx="2554360" cy="905756"/>
-                      </a:xfrm>
-                      <a:prstGeom prst="rect">
-                        <a:avLst/>
-                      </a:prstGeom>
-                      <a:noFill/>
-                      <a:ln>
-                        <a:noFill/>
-                      </a:ln>
-                      <a:effectLst/>
-                    </p:spPr>
-                  </p:pic>
-                </p:oleObj>
-              </mc:Fallback>
-            </mc:AlternateContent>
-          </a:graphicData>
-        </a:graphic>
-      </p:graphicFrame>
       <p:sp>
         <p:nvSpPr>
           <p:cNvPr id="2" name="TextBox 1"/>
@@ -16873,6 +16710,61 @@
                 </a:solidFill>
               </a:rPr>
               <a:t>Group Work</a:t>
+            </a:r>
+          </a:p>
+        </p:txBody>
+      </p:sp>
+      <p:sp>
+        <p:nvSpPr>
+          <p:cNvPr id="6148" name="TextBox 6147"/>
+          <p:cNvSpPr txBox="1"/>
+          <p:nvPr/>
+        </p:nvSpPr>
+        <p:spPr>
+          <a:xfrm>
+            <a:off x="4818820" y="4919723"/>
+            <a:ext cx="3094892" cy="905756"/>
+          </a:xfrm>
+          <a:prstGeom prst="rect">
+            <a:avLst/>
+          </a:prstGeom>
+          <a:noFill/>
+        </p:spPr>
+        <p:txBody>
+          <a:bodyPr wrap="square" anchor="ctr" lIns="0" rIns="0" tIns="0" bIns="0">
+            <a:spAutoFit/>
+          </a:bodyPr>
+          <a:lstStyle/>
+          <a:p>
+            <a:r>
+              <a:rPr sz="1900">
+                <a:latin typeface="Cambria"/>
+              </a:rPr>
+              <a:t>P(X = x) = μ</a:t>
+            </a:r>
+            <a:r>
+              <a:rPr sz="1900" baseline="30000">
+                <a:latin typeface="Cambria"/>
+              </a:rPr>
+              <a:t>x</a:t>
+            </a:r>
+            <a:r>
+              <a:rPr sz="1900">
+                <a:latin typeface="Cambria"/>
+              </a:rPr>
+              <a:t> e</a:t>
+            </a:r>
+            <a:r>
+              <a:rPr sz="1900" baseline="30000">
+                <a:latin typeface="Cambria"/>
+              </a:rPr>
+              <a:t>−μ</a:t>
+            </a:r>
+            <a:r>
+              <a:rPr sz="1900">
+                <a:latin typeface="Cambria"/>
+              </a:rPr>
+              <a:t> / x!</a:t>
             </a:r>
           </a:p>
         </p:txBody>
@@ -17470,10 +17362,8 @@
               <a:t> </a:t>
             </a:r>
             <a:r>
-              <a:rPr lang="en-US" altLang="en-US" dirty="0">
-                <a:sym typeface="Wingdings"/>
-              </a:rPr>
-              <a:t> Onward to negative binomial!</a:t>
+              <a:rPr lang="en-US" altLang="en-US" dirty="0"/>
+              <a:t>→ Onward to negative binomial!</a:t>
             </a:r>
             <a:endParaRPr lang="en-US" altLang="en-US" dirty="0"/>
           </a:p>
@@ -21384,77 +21274,6 @@
           </a:p>
         </p:txBody>
       </p:sp>
-      <p:graphicFrame>
-        <p:nvGraphicFramePr>
-          <p:cNvPr id="143362" name="Object 4"/>
-          <p:cNvGraphicFramePr>
-            <a:graphicFrameLocks noGrp="1" noChangeAspect="1"/>
-          </p:cNvGraphicFramePr>
-          <p:nvPr>
-            <p:ph idx="1"/>
-            <p:extLst>
-              <p:ext uri="{D42A27DB-BD31-4B8C-83A1-F6EECF244321}">
-                <p14:modId xmlns:p14="http://schemas.microsoft.com/office/powerpoint/2010/main" val="2017998080"/>
-              </p:ext>
-            </p:extLst>
-          </p:nvPr>
-        </p:nvGraphicFramePr>
-        <p:xfrm>
-          <a:off x="2101534" y="2770188"/>
-          <a:ext cx="8801398" cy="2033032"/>
-        </p:xfrm>
-        <a:graphic>
-          <a:graphicData uri="http://schemas.openxmlformats.org/presentationml/2006/ole">
-            <mc:AlternateContent xmlns:mc="http://schemas.openxmlformats.org/markup-compatibility/2006">
-              <mc:Choice xmlns:v="urn:schemas-microsoft-com:vml" Requires="v">
-                <p:oleObj name="Equation" r:id="rId3" imgW="3847204" imgH="889046" progId="">
-                  <p:embed/>
-                </p:oleObj>
-              </mc:Choice>
-              <mc:Fallback>
-                <p:oleObj name="Equation" r:id="rId3" imgW="3847204" imgH="889046" progId="">
-                  <p:embed/>
-                  <p:pic>
-                    <p:nvPicPr>
-                      <p:cNvPr id="0" name=""/>
-                      <p:cNvPicPr>
-                        <a:picLocks noGrp="1" noChangeAspect="1" noChangeArrowheads="1"/>
-                      </p:cNvPicPr>
-                      <p:nvPr/>
-                    </p:nvPicPr>
-                    <p:blipFill>
-                      <a:blip r:embed="rId4">
-                        <a:extLst>
-                          <a:ext uri="{28A0092B-C50C-407E-A947-70E740481C1C}">
-                            <a14:useLocalDpi xmlns:a14="http://schemas.microsoft.com/office/drawing/2010/main" val="0"/>
-                          </a:ext>
-                        </a:extLst>
-                      </a:blip>
-                      <a:srcRect/>
-                      <a:stretch>
-                        <a:fillRect/>
-                      </a:stretch>
-                    </p:blipFill>
-                    <p:spPr bwMode="auto">
-                      <a:xfrm>
-                        <a:off x="2101534" y="2770188"/>
-                        <a:ext cx="8801398" cy="2033032"/>
-                      </a:xfrm>
-                      <a:prstGeom prst="rect">
-                        <a:avLst/>
-                      </a:prstGeom>
-                      <a:noFill/>
-                      <a:ln>
-                        <a:noFill/>
-                      </a:ln>
-                    </p:spPr>
-                  </p:pic>
-                </p:oleObj>
-              </mc:Fallback>
-            </mc:AlternateContent>
-          </a:graphicData>
-        </a:graphic>
-      </p:graphicFrame>
       <p:sp>
         <p:nvSpPr>
           <p:cNvPr id="143363" name="Rectangle 4"/>
@@ -22026,6 +21845,61 @@
               <a:t>Also N</a:t>
             </a:r>
             <a:endParaRPr lang="en-US" sz="2800" i="1" dirty="0"/>
+          </a:p>
+        </p:txBody>
+      </p:sp>
+      <p:sp>
+        <p:nvSpPr>
+          <p:cNvPr id="143365" name="TextBox 143364"/>
+          <p:cNvSpPr txBox="1"/>
+          <p:nvPr/>
+        </p:nvSpPr>
+        <p:spPr>
+          <a:xfrm>
+            <a:off x="2101534" y="2770188"/>
+            <a:ext cx="8801398" cy="2033032"/>
+          </a:xfrm>
+          <a:prstGeom prst="rect">
+            <a:avLst/>
+          </a:prstGeom>
+          <a:noFill/>
+        </p:spPr>
+        <p:txBody>
+          <a:bodyPr wrap="square" anchor="ctr" lIns="0" rIns="0" tIns="0" bIns="0">
+            <a:spAutoFit/>
+          </a:bodyPr>
+          <a:lstStyle/>
+          <a:p>
+            <a:r>
+              <a:rPr sz="1700">
+                <a:latin typeface="Cambria"/>
+              </a:rPr>
+              <a:t>n            The number of times a trial is repeated</a:t>
+            </a:r>
+          </a:p>
+          <a:p>
+            <a:r>
+              <a:rPr sz="1700">
+                <a:latin typeface="Cambria"/>
+              </a:rPr>
+              <a:t>p = P(S)     The probability of a success in a single trial</a:t>
+            </a:r>
+          </a:p>
+          <a:p>
+            <a:r>
+              <a:rPr sz="1700">
+                <a:latin typeface="Cambria"/>
+              </a:rPr>
+              <a:t>q = P(F)     The probability of a failure in a single trial, q = 1 − p</a:t>
+            </a:r>
+          </a:p>
+          <a:p>
+            <a:r>
+              <a:rPr sz="1700">
+                <a:latin typeface="Cambria"/>
+              </a:rPr>
+              <a:t>x            The number of successes on n trials (x = 0, 1, .., n)</a:t>
+            </a:r>
           </a:p>
         </p:txBody>
       </p:sp>
@@ -27539,77 +27413,6 @@
           </a:p>
         </p:txBody>
       </p:sp>
-      <p:graphicFrame>
-        <p:nvGraphicFramePr>
-          <p:cNvPr id="145411" name="Object 4"/>
-          <p:cNvGraphicFramePr>
-            <a:graphicFrameLocks noGrp="1" noChangeAspect="1"/>
-          </p:cNvGraphicFramePr>
-          <p:nvPr>
-            <p:ph sz="half" idx="2"/>
-            <p:extLst>
-              <p:ext uri="{D42A27DB-BD31-4B8C-83A1-F6EECF244321}">
-                <p14:modId xmlns:p14="http://schemas.microsoft.com/office/powerpoint/2010/main" val="575213071"/>
-              </p:ext>
-            </p:extLst>
-          </p:nvPr>
-        </p:nvGraphicFramePr>
-        <p:xfrm>
-          <a:off x="3733623" y="2011680"/>
-          <a:ext cx="4785714" cy="867410"/>
-        </p:xfrm>
-        <a:graphic>
-          <a:graphicData uri="http://schemas.openxmlformats.org/presentationml/2006/ole">
-            <mc:AlternateContent xmlns:mc="http://schemas.openxmlformats.org/markup-compatibility/2006">
-              <mc:Choice xmlns:v="urn:schemas-microsoft-com:vml" Requires="v">
-                <p:oleObj name="Equation" r:id="rId3" imgW="2311078" imgH="418893" progId="">
-                  <p:embed/>
-                </p:oleObj>
-              </mc:Choice>
-              <mc:Fallback>
-                <p:oleObj name="Equation" r:id="rId3" imgW="2311078" imgH="418893" progId="">
-                  <p:embed/>
-                  <p:pic>
-                    <p:nvPicPr>
-                      <p:cNvPr id="0" name=""/>
-                      <p:cNvPicPr>
-                        <a:picLocks noGrp="1" noChangeAspect="1" noChangeArrowheads="1"/>
-                      </p:cNvPicPr>
-                      <p:nvPr/>
-                    </p:nvPicPr>
-                    <p:blipFill>
-                      <a:blip r:embed="rId4">
-                        <a:extLst>
-                          <a:ext uri="{28A0092B-C50C-407E-A947-70E740481C1C}">
-                            <a14:useLocalDpi xmlns:a14="http://schemas.microsoft.com/office/drawing/2010/main" val="0"/>
-                          </a:ext>
-                        </a:extLst>
-                      </a:blip>
-                      <a:srcRect/>
-                      <a:stretch>
-                        <a:fillRect/>
-                      </a:stretch>
-                    </p:blipFill>
-                    <p:spPr bwMode="auto">
-                      <a:xfrm>
-                        <a:off x="3733623" y="2011680"/>
-                        <a:ext cx="4785714" cy="867410"/>
-                      </a:xfrm>
-                      <a:prstGeom prst="rect">
-                        <a:avLst/>
-                      </a:prstGeom>
-                      <a:noFill/>
-                      <a:ln>
-                        <a:noFill/>
-                      </a:ln>
-                    </p:spPr>
-                  </p:pic>
-                </p:oleObj>
-              </mc:Fallback>
-            </mc:AlternateContent>
-          </a:graphicData>
-        </a:graphic>
-      </p:graphicFrame>
       <p:cxnSp>
         <p:nvCxnSpPr>
           <p:cNvPr id="3" name="Straight Arrow Connector 2"/>
@@ -27697,6 +27500,103 @@
           </a:p>
         </p:txBody>
       </p:sp>
+      <p:sp>
+        <p:nvSpPr>
+          <p:cNvPr id="7172" name="TextBox 7171"/>
+          <p:cNvSpPr txBox="1"/>
+          <p:nvPr/>
+        </p:nvSpPr>
+        <p:spPr>
+          <a:xfrm>
+            <a:off x="3733623" y="2011680"/>
+            <a:ext cx="6893169" cy="867410"/>
+          </a:xfrm>
+          <a:prstGeom prst="rect">
+            <a:avLst/>
+          </a:prstGeom>
+          <a:noFill/>
+        </p:spPr>
+        <p:txBody>
+          <a:bodyPr wrap="square" anchor="ctr" lIns="0" rIns="0" tIns="0" bIns="0">
+            <a:spAutoFit/>
+          </a:bodyPr>
+          <a:lstStyle/>
+          <a:p>
+            <a:r>
+              <a:rPr sz="1900">
+                <a:latin typeface="Cambria"/>
+              </a:rPr>
+              <a:t>P(x) = </a:t>
+            </a:r>
+            <a:r>
+              <a:rPr sz="1900" baseline="-25000">
+                <a:latin typeface="Cambria"/>
+              </a:rPr>
+              <a:t>n</a:t>
+            </a:r>
+            <a:r>
+              <a:rPr sz="1900">
+                <a:latin typeface="Cambria"/>
+              </a:rPr>
+              <a:t>C</a:t>
+            </a:r>
+            <a:r>
+              <a:rPr sz="1900" baseline="-25000">
+                <a:latin typeface="Cambria"/>
+              </a:rPr>
+              <a:t>x</a:t>
+            </a:r>
+            <a:r>
+              <a:rPr sz="1900">
+                <a:latin typeface="Cambria"/>
+              </a:rPr>
+              <a:t> p</a:t>
+            </a:r>
+            <a:r>
+              <a:rPr sz="1900" baseline="30000">
+                <a:latin typeface="Cambria"/>
+              </a:rPr>
+              <a:t>x</a:t>
+            </a:r>
+            <a:r>
+              <a:rPr sz="1900">
+                <a:latin typeface="Cambria"/>
+              </a:rPr>
+              <a:t> q</a:t>
+            </a:r>
+            <a:r>
+              <a:rPr sz="1900" baseline="30000">
+                <a:latin typeface="Cambria"/>
+              </a:rPr>
+              <a:t>n−x</a:t>
+            </a:r>
+            <a:r>
+              <a:rPr sz="1900">
+                <a:latin typeface="Cambria"/>
+              </a:rPr>
+              <a:t> = n! / ((n − x)! x!) · p</a:t>
+            </a:r>
+            <a:r>
+              <a:rPr sz="1900" baseline="30000">
+                <a:latin typeface="Cambria"/>
+              </a:rPr>
+              <a:t>x</a:t>
+            </a:r>
+            <a:r>
+              <a:rPr sz="1900">
+                <a:latin typeface="Cambria"/>
+              </a:rPr>
+              <a:t> q</a:t>
+            </a:r>
+            <a:r>
+              <a:rPr sz="1900" baseline="30000">
+                <a:latin typeface="Cambria"/>
+              </a:rPr>
+              <a:t>n−x</a:t>
+            </a:r>
+          </a:p>
+        </p:txBody>
+      </p:sp>
     </p:spTree>
     <p:extLst>
       <p:ext uri="{BB962C8B-B14F-4D97-AF65-F5344CB8AC3E}">
@@ -27940,10 +27840,8 @@
               <a:t>Bernoulli </a:t>
             </a:r>
             <a:r>
-              <a:rPr lang="en-US" sz="2600" dirty="0">
-                <a:sym typeface="Wingdings"/>
-              </a:rPr>
-              <a:t> probability a single coin flip comes up heads</a:t>
+              <a:rPr lang="en-US" sz="2600" dirty="0"/>
+              <a:t>→ probability a single coin flip comes up heads</a:t>
             </a:r>
           </a:p>
           <a:p>
@@ -27954,10 +27852,8 @@
               <a:defRPr/>
             </a:pPr>
             <a:r>
-              <a:rPr lang="en-US" sz="2600" dirty="0">
-                <a:sym typeface="Wingdings"/>
-              </a:rPr>
-              <a:t>Binomial  Probability that 10 coin flips yield 3 heads</a:t>
+              <a:rPr lang="en-US" sz="2600" dirty="0"/>
+              <a:t>Binomial → Probability that 10 coin flips yield 3 heads</a:t>
             </a:r>
           </a:p>
           <a:p>
@@ -27995,77 +27891,103 @@
           </a:p>
         </p:txBody>
       </p:sp>
-      <p:graphicFrame>
-        <p:nvGraphicFramePr>
-          <p:cNvPr id="147459" name="Object 4"/>
-          <p:cNvGraphicFramePr>
-            <a:graphicFrameLocks noGrp="1" noChangeAspect="1"/>
-          </p:cNvGraphicFramePr>
-          <p:nvPr>
-            <p:ph sz="half" idx="2"/>
-            <p:extLst>
-              <p:ext uri="{D42A27DB-BD31-4B8C-83A1-F6EECF244321}">
-                <p14:modId xmlns:p14="http://schemas.microsoft.com/office/powerpoint/2010/main" val="1561546922"/>
-              </p:ext>
-            </p:extLst>
-          </p:nvPr>
-        </p:nvGraphicFramePr>
-        <p:xfrm>
-          <a:off x="3703003" y="1617028"/>
-          <a:ext cx="4573752" cy="828992"/>
-        </p:xfrm>
-        <a:graphic>
-          <a:graphicData uri="http://schemas.openxmlformats.org/presentationml/2006/ole">
-            <mc:AlternateContent xmlns:mc="http://schemas.openxmlformats.org/markup-compatibility/2006">
-              <mc:Choice xmlns:v="urn:schemas-microsoft-com:vml" Requires="v">
-                <p:oleObj name="Equation" r:id="rId3" imgW="2311078" imgH="418893" progId="">
-                  <p:embed/>
-                </p:oleObj>
-              </mc:Choice>
-              <mc:Fallback>
-                <p:oleObj name="Equation" r:id="rId3" imgW="2311078" imgH="418893" progId="">
-                  <p:embed/>
-                  <p:pic>
-                    <p:nvPicPr>
-                      <p:cNvPr id="0" name=""/>
-                      <p:cNvPicPr>
-                        <a:picLocks noGrp="1" noChangeAspect="1" noChangeArrowheads="1"/>
-                      </p:cNvPicPr>
-                      <p:nvPr/>
-                    </p:nvPicPr>
-                    <p:blipFill>
-                      <a:blip r:embed="rId4">
-                        <a:extLst>
-                          <a:ext uri="{28A0092B-C50C-407E-A947-70E740481C1C}">
-                            <a14:useLocalDpi xmlns:a14="http://schemas.microsoft.com/office/drawing/2010/main" val="0"/>
-                          </a:ext>
-                        </a:extLst>
-                      </a:blip>
-                      <a:srcRect/>
-                      <a:stretch>
-                        <a:fillRect/>
-                      </a:stretch>
-                    </p:blipFill>
-                    <p:spPr bwMode="auto">
-                      <a:xfrm>
-                        <a:off x="3703003" y="1617028"/>
-                        <a:ext cx="4573752" cy="828992"/>
-                      </a:xfrm>
-                      <a:prstGeom prst="rect">
-                        <a:avLst/>
-                      </a:prstGeom>
-                      <a:noFill/>
-                      <a:ln>
-                        <a:noFill/>
-                      </a:ln>
-                    </p:spPr>
-                  </p:pic>
-                </p:oleObj>
-              </mc:Fallback>
-            </mc:AlternateContent>
-          </a:graphicData>
-        </a:graphic>
-      </p:graphicFrame>
+      <p:sp>
+        <p:nvSpPr>
+          <p:cNvPr id="7172" name="TextBox 7171"/>
+          <p:cNvSpPr txBox="1"/>
+          <p:nvPr/>
+        </p:nvSpPr>
+        <p:spPr>
+          <a:xfrm>
+            <a:off x="3703003" y="1617028"/>
+            <a:ext cx="6893169" cy="828992"/>
+          </a:xfrm>
+          <a:prstGeom prst="rect">
+            <a:avLst/>
+          </a:prstGeom>
+          <a:noFill/>
+        </p:spPr>
+        <p:txBody>
+          <a:bodyPr wrap="square" anchor="ctr" lIns="0" rIns="0" tIns="0" bIns="0">
+            <a:spAutoFit/>
+          </a:bodyPr>
+          <a:lstStyle/>
+          <a:p>
+            <a:r>
+              <a:rPr sz="1900">
+                <a:latin typeface="Cambria"/>
+              </a:rPr>
+              <a:t>P(x) = </a:t>
+            </a:r>
+            <a:r>
+              <a:rPr sz="1900" baseline="-25000">
+                <a:latin typeface="Cambria"/>
+              </a:rPr>
+              <a:t>n</a:t>
+            </a:r>
+            <a:r>
+              <a:rPr sz="1900">
+                <a:latin typeface="Cambria"/>
+              </a:rPr>
+              <a:t>C</a:t>
+            </a:r>
+            <a:r>
+              <a:rPr sz="1900" baseline="-25000">
+                <a:latin typeface="Cambria"/>
+              </a:rPr>
+              <a:t>x</a:t>
+            </a:r>
+            <a:r>
+              <a:rPr sz="1900">
+                <a:latin typeface="Cambria"/>
+              </a:rPr>
+              <a:t> p</a:t>
+            </a:r>
+            <a:r>
+              <a:rPr sz="1900" baseline="30000">
+                <a:latin typeface="Cambria"/>
+              </a:rPr>
+              <a:t>x</a:t>
+            </a:r>
+            <a:r>
+              <a:rPr sz="1900">
+                <a:latin typeface="Cambria"/>
+              </a:rPr>
+              <a:t> q</a:t>
+            </a:r>
+            <a:r>
+              <a:rPr sz="1900" baseline="30000">
+                <a:latin typeface="Cambria"/>
+              </a:rPr>
+              <a:t>n−x</a:t>
+            </a:r>
+            <a:r>
+              <a:rPr sz="1900">
+                <a:latin typeface="Cambria"/>
+              </a:rPr>
+              <a:t> = n! / ((n − x)! x!) · p</a:t>
+            </a:r>
+            <a:r>
+              <a:rPr sz="1900" baseline="30000">
+                <a:latin typeface="Cambria"/>
+              </a:rPr>
+              <a:t>x</a:t>
+            </a:r>
+            <a:r>
+              <a:rPr sz="1900">
+                <a:latin typeface="Cambria"/>
+              </a:rPr>
+              <a:t> q</a:t>
+            </a:r>
+            <a:r>
+              <a:rPr sz="1900" baseline="30000">
+                <a:latin typeface="Cambria"/>
+              </a:rPr>
+              <a:t>n−x</a:t>
+            </a:r>
+          </a:p>
+        </p:txBody>
+      </p:sp>
     </p:spTree>
     <p:extLst>
       <p:ext uri="{BB962C8B-B14F-4D97-AF65-F5344CB8AC3E}">
@@ -28714,91 +28636,6 @@
           </a:p>
         </p:txBody>
       </p:sp>
-      <p:graphicFrame>
-        <p:nvGraphicFramePr>
-          <p:cNvPr id="149508" name="Object 9"/>
-          <p:cNvGraphicFramePr>
-            <a:graphicFrameLocks noGrp="1" noChangeAspect="1"/>
-          </p:cNvGraphicFramePr>
-          <p:nvPr>
-            <p:ph sz="quarter" idx="3"/>
-          </p:nvPr>
-        </p:nvGraphicFramePr>
-        <p:xfrm>
-          <a:off x="4924425" y="4114800"/>
-          <a:ext cx="2514600" cy="914400"/>
-        </p:xfrm>
-        <a:graphic>
-          <a:graphicData uri="http://schemas.openxmlformats.org/presentationml/2006/ole">
-            <mc:AlternateContent xmlns:mc="http://schemas.openxmlformats.org/markup-compatibility/2006">
-              <mc:Choice xmlns:v="urn:schemas-microsoft-com:vml" Requires="v">
-                <p:oleObj name="Equation" r:id="rId3" imgW="1257231" imgH="456924" progId="">
-                  <p:embed/>
-                </p:oleObj>
-              </mc:Choice>
-              <mc:Fallback>
-                <p:oleObj name="Equation" r:id="rId3" imgW="1257231" imgH="456924" progId="">
-                  <p:embed/>
-                  <p:pic>
-                    <p:nvPicPr>
-                      <p:cNvPr id="0" name=""/>
-                      <p:cNvPicPr>
-                        <a:picLocks noGrp="1" noChangeAspect="1" noChangeArrowheads="1"/>
-                      </p:cNvPicPr>
-                      <p:nvPr/>
-                    </p:nvPicPr>
-                    <p:blipFill>
-                      <a:blip r:embed="rId4">
-                        <a:extLst>
-                          <a:ext uri="{28A0092B-C50C-407E-A947-70E740481C1C}">
-                            <a14:useLocalDpi xmlns:a14="http://schemas.microsoft.com/office/drawing/2010/main" val="0"/>
-                          </a:ext>
-                        </a:extLst>
-                      </a:blip>
-                      <a:srcRect/>
-                      <a:stretch>
-                        <a:fillRect/>
-                      </a:stretch>
-                    </p:blipFill>
-                    <p:spPr bwMode="auto">
-                      <a:xfrm>
-                        <a:off x="4924425" y="4114800"/>
-                        <a:ext cx="2514600" cy="914400"/>
-                      </a:xfrm>
-                      <a:prstGeom prst="rect">
-                        <a:avLst/>
-                      </a:prstGeom>
-                      <a:noFill/>
-                      <a:ln>
-                        <a:noFill/>
-                      </a:ln>
-                      <a:extLst>
-                        <a:ext uri="{909E8E84-426E-40DD-AFC4-6F175D3DCCD1}">
-                          <a14:hiddenFill xmlns:a14="http://schemas.microsoft.com/office/drawing/2010/main">
-                            <a:solidFill>
-                              <a:srgbClr val="FFFFFF"/>
-                            </a:solidFill>
-                          </a14:hiddenFill>
-                        </a:ext>
-                        <a:ext uri="{91240B29-F687-4F45-9708-019B960494DF}">
-                          <a14:hiddenLine xmlns:a14="http://schemas.microsoft.com/office/drawing/2010/main" w="9525">
-                            <a:solidFill>
-                              <a:schemeClr val="tx1"/>
-                            </a:solidFill>
-                            <a:miter lim="800000"/>
-                            <a:headEnd/>
-                            <a:tailEnd/>
-                          </a14:hiddenLine>
-                        </a:ext>
-                      </a:extLst>
-                    </p:spPr>
-                  </p:pic>
-                </p:oleObj>
-              </mc:Fallback>
-            </mc:AlternateContent>
-          </a:graphicData>
-        </a:graphic>
-      </p:graphicFrame>
       <p:sp>
         <p:nvSpPr>
           <p:cNvPr id="6" name="TextBox 5"/>
@@ -28893,6 +28730,57 @@
               <a:t>)</a:t>
             </a:r>
             <a:endParaRPr lang="en-US" sz="2800" i="1" dirty="0"/>
+          </a:p>
+        </p:txBody>
+      </p:sp>
+      <p:sp>
+        <p:nvSpPr>
+          <p:cNvPr id="8196" name="TextBox 8195"/>
+          <p:cNvSpPr txBox="1"/>
+          <p:nvPr/>
+        </p:nvSpPr>
+        <p:spPr>
+          <a:xfrm>
+            <a:off x="4924425" y="4114800"/>
+            <a:ext cx="2514600" cy="914400"/>
+          </a:xfrm>
+          <a:prstGeom prst="rect">
+            <a:avLst/>
+          </a:prstGeom>
+          <a:noFill/>
+        </p:spPr>
+        <p:txBody>
+          <a:bodyPr wrap="square" anchor="ctr" lIns="0" rIns="0" tIns="0" bIns="0">
+            <a:spAutoFit/>
+          </a:bodyPr>
+          <a:lstStyle/>
+          <a:p>
+            <a:r>
+              <a:rPr sz="1800">
+                <a:latin typeface="Cambria"/>
+              </a:rPr>
+              <a:t>Mean : μ = n p</a:t>
+            </a:r>
+          </a:p>
+          <a:p>
+            <a:r>
+              <a:rPr sz="1800">
+                <a:latin typeface="Cambria"/>
+              </a:rPr>
+              <a:t>Variance : σ</a:t>
+            </a:r>
+            <a:r>
+              <a:rPr sz="1800" baseline="30000">
+                <a:latin typeface="Cambria"/>
+              </a:rPr>
+              <a:t>2</a:t>
+            </a:r>
+            <a:r>
+              <a:rPr sz="1800">
+                <a:latin typeface="Cambria"/>
+              </a:rPr>
+              <a:t> = npq</a:t>
+            </a:r>
           </a:p>
         </p:txBody>
       </p:sp>

</xml_diff>